<commit_message>
docs(presentation): 진행 단계(Phase 1~5)와 Andon 장 추가
로드맵을 넣는 이상 어느 조건에서 멈추는지가 같이 있어야 계획이 계획으로
읽힌다. CouSolve 프레임워크의 Andon(중단 여부를 결정할 기준)을 그대로 쓴다.

- 6. 진행 단계 — 단계/무엇을/출하 시 확인할 것/상태 4열 표. '확인할 것'은
  ROADMAP 각 Phase 의 '출하 상태' 문구를 그대로 옮겼다. 하단에 이 순서인
  이유 2건(측정 수단이 먼저 · 단계별 단독 배포)
- 7. Andon — 중단 기준 4건과 조치 방법 4건을 좌우로. 기준은 지어내지 않았다:
  동작 보존 실패=Phase 3 REFACTOR-04 게이트, CI 적색=release.yml 테스트 게이트,
  UWB 파손=alpha09 파괴 변경 리스크, 롤백=UpdateManager 자동 업데이트 경로

make_base.py 신설 — 사내 폼에서 base.pptx 를 만드는 절차를 스크립트로 옮겼다.
README 에 수기로 적어 두던 6단계를 인자 하나로 대체한다 (본문 장 수 가변).

7장 → 9장. 근거 대응표는 README.

Co-Authored-By: Claude Opus 5 <noreply@anthropic.com>
Claude-Session: https://claude.ai/code/session_01H236zJFBe6FYBpza3hfm97
</commit_message>
<xml_diff>
--- a/docs/presentation/company_form/SafeAlert_보고_2026.08.pptx
+++ b/docs/presentation/company_form/SafeAlert_보고_2026.08.pptx
@@ -11,6 +11,8 @@
     <p:sldId id="256" r:id="rId6"/>
     <p:sldId id="342" r:id="rId7"/>
     <p:sldId id="394" r:id="rId9"/>
+    <p:sldId id="400" r:id="rId33"/>
+    <p:sldId id="399" r:id="rId32"/>
     <p:sldId id="398" r:id="rId31"/>
     <p:sldId id="397" r:id="rId30"/>
     <p:sldId id="396" r:id="rId29"/>
@@ -3824,6 +3826,34 @@
               <a:t xml:space="preserve">  2) 시연 영상 · 판정 시뮬레이터</a:t>
             </a:r>
           </a:p>
+          <a:p>
+            <a:r>
+              <a:rPr lang="en-US" altLang="ko-KR" dirty="0"/>
+              <a:t xml:space="preserve"> </a:t>
+            </a:r>
+            <a:endParaRPr lang="en-US" altLang="ko-KR" dirty="0"/>
+          </a:p>
+          <a:p>
+            <a:r>
+              <a:rPr lang="en-US" altLang="ko-KR" dirty="0"/>
+              <a:t xml:space="preserve">6. 진행 단계 (Phase 1 ~ 5)</a:t>
+            </a:r>
+            <a:endParaRPr lang="en-US" altLang="ko-KR" dirty="0"/>
+          </a:p>
+          <a:p>
+            <a:r>
+              <a:rPr lang="en-US" altLang="ko-KR" dirty="0"/>
+              <a:t xml:space="preserve"> </a:t>
+            </a:r>
+            <a:endParaRPr lang="en-US" altLang="ko-KR" dirty="0"/>
+          </a:p>
+          <a:p>
+            <a:r>
+              <a:rPr lang="en-US" altLang="ko-KR" dirty="0"/>
+              <a:t xml:space="preserve">7. Andon — 중단 · 롤백 기준</a:t>
+            </a:r>
+            <a:endParaRPr lang="en-US" altLang="ko-KR" dirty="0"/>
+          </a:p>
         </p:txBody>
       </p:sp>
     </p:spTree>
@@ -8753,6 +8783,2302 @@
       </p:par>
     </p:tnLst>
   </p:timing>
+</p:sld>
+</file>
+
+<file path=ppt/slides/slide8.xml><?xml version="1.0" encoding="utf-8"?>
+<p:sld xmlns:a="http://schemas.openxmlformats.org/drawingml/2006/main" xmlns:r="http://schemas.openxmlformats.org/officeDocument/2006/relationships" xmlns:p="http://schemas.openxmlformats.org/presentationml/2006/main">
+  <p:cSld>
+    <p:spTree>
+      <p:nvGrpSpPr>
+        <p:cNvPr id="1" name="">
+          <a:extLst>
+            <a:ext uri="{FF2B5EF4-FFF2-40B4-BE49-F238E27FC236}">
+              <a16:creationId xmlns:a16="http://schemas.microsoft.com/office/drawing/2014/main" id="{E4EFD6F4-EBDD-9AC2-DC28-2DDF0C04A565}"/>
+            </a:ext>
+          </a:extLst>
+        </p:cNvPr>
+        <p:cNvGrpSpPr/>
+        <p:nvPr/>
+      </p:nvGrpSpPr>
+      <p:grpSpPr>
+        <a:xfrm>
+          <a:off x="0" y="0"/>
+          <a:ext cx="0" cy="0"/>
+          <a:chOff x="0" y="0"/>
+          <a:chExt cx="0" cy="0"/>
+        </a:xfrm>
+      </p:grpSpPr>
+      <p:sp>
+        <p:nvSpPr>
+          <p:cNvPr id="5" name="제목 1">
+            <a:extLst>
+              <a:ext uri="{FF2B5EF4-FFF2-40B4-BE49-F238E27FC236}">
+                <a16:creationId xmlns:a16="http://schemas.microsoft.com/office/drawing/2014/main" id="{3462F1EA-748D-175E-1C14-5E9984552716}"/>
+              </a:ext>
+            </a:extLst>
+          </p:cNvPr>
+          <p:cNvSpPr txBox="1">
+            <a:spLocks/>
+          </p:cNvSpPr>
+          <p:nvPr/>
+        </p:nvSpPr>
+        <p:spPr>
+          <a:xfrm>
+            <a:off x="636390" y="928122"/>
+            <a:ext cx="11342595" cy="3980770"/>
+          </a:xfrm>
+          <a:prstGeom prst="rect">
+            <a:avLst/>
+          </a:prstGeom>
+          <a:noFill/>
+        </p:spPr>
+        <p:txBody>
+          <a:bodyPr vert="horz" wrap="square" lIns="91440" tIns="45720" rIns="91440" bIns="45720" rtlCol="0" anchor="t">
+            <a:spAutoFit/>
+          </a:bodyPr>
+          <a:lstStyle>
+            <a:lvl1pPr marL="0" indent="0" algn="l" defTabSz="914400" rtl="0" eaLnBrk="1" latinLnBrk="1" hangingPunct="1">
+              <a:lnSpc>
+                <a:spcPct val="100000"/>
+              </a:lnSpc>
+              <a:spcBef>
+                <a:spcPct val="0"/>
+              </a:spcBef>
+              <a:buNone/>
+              <a:defRPr lang="en-US" sz="1600" b="1" kern="1200" dirty="0">
+                <a:solidFill>
+                  <a:srgbClr val="560000"/>
+                </a:solidFill>
+                <a:latin typeface="+mj-ea"/>
+                <a:ea typeface="+mj-ea"/>
+                <a:cs typeface="+mn-cs"/>
+              </a:defRPr>
+            </a:lvl1pPr>
+          </a:lstStyle>
+          <a:p>
+            <a:pPr>
+              <a:lnSpc>
+                <a:spcPct val="150000"/>
+              </a:lnSpc>
+            </a:pPr>
+            <a:endParaRPr lang="en-US" altLang="ko-KR" sz="1400" dirty="0">
+              <a:solidFill>
+                <a:schemeClr val="tx1"/>
+              </a:solidFill>
+              <a:latin typeface="+mn-ea"/>
+              <a:ea typeface="+mn-ea"/>
+            </a:endParaRPr>
+          </a:p>
+        </p:txBody>
+      </p:sp>
+      <p:sp>
+        <p:nvSpPr>
+          <p:cNvPr id="2" name="제목 1">
+            <a:extLst>
+              <a:ext uri="{FF2B5EF4-FFF2-40B4-BE49-F238E27FC236}">
+                <a16:creationId xmlns:a16="http://schemas.microsoft.com/office/drawing/2014/main" id="{54B5B938-7AFE-1302-EB19-024D633AA023}"/>
+              </a:ext>
+            </a:extLst>
+          </p:cNvPr>
+          <p:cNvSpPr>
+            <a:spLocks noGrp="1"/>
+          </p:cNvSpPr>
+          <p:nvPr>
+            <p:ph type="title"/>
+          </p:nvPr>
+        </p:nvSpPr>
+        <p:spPr>
+          <a:xfrm>
+            <a:off x="636391" y="595686"/>
+            <a:ext cx="11293263" cy="338554"/>
+          </a:xfrm>
+        </p:spPr>
+        <p:txBody>
+          <a:bodyPr/>
+          <a:lstStyle/>
+          <a:p>
+            <a:r>
+              <a:rPr lang="en-US" altLang="ko-KR" dirty="0">
+                <a:latin typeface="맑은 고딕" panose="020B0503020000020004" pitchFamily="50" charset="-127"/>
+                <a:ea typeface="맑은 고딕" panose="020B0503020000020004" pitchFamily="50" charset="-127"/>
+              </a:rPr>
+              <a:t>6. 진행 단계</a:t>
+            </a:r>
+            <a:endParaRPr lang="ko-KR" altLang="en-US" dirty="0"/>
+          </a:p>
+        </p:txBody>
+      </p:sp>
+      <p:sp>
+        <p:nvSpPr>
+          <p:cNvPr id="12" name="슬라이드 번호 개체 틀 11">
+            <a:extLst>
+              <a:ext uri="{FF2B5EF4-FFF2-40B4-BE49-F238E27FC236}">
+                <a16:creationId xmlns:a16="http://schemas.microsoft.com/office/drawing/2014/main" id="{B7184ABC-D9FC-E120-072A-5615A9569176}"/>
+              </a:ext>
+            </a:extLst>
+          </p:cNvPr>
+          <p:cNvSpPr>
+            <a:spLocks noGrp="1"/>
+          </p:cNvSpPr>
+          <p:nvPr>
+            <p:ph type="sldNum" sz="quarter" idx="12"/>
+          </p:nvPr>
+        </p:nvSpPr>
+        <p:spPr/>
+        <p:txBody>
+          <a:bodyPr/>
+          <a:lstStyle/>
+          <a:p>
+            <a:fld id="{A2CF8A37-2FCE-495B-9275-FE23C56C2D36}" type="slidenum">
+              <a:rPr lang="ko-KR" altLang="en-US" smtClean="0"/>
+              <a:pPr/>
+              <a:t>4</a:t>
+            </a:fld>
+            <a:endParaRPr lang="ko-KR" altLang="en-US" dirty="0"/>
+          </a:p>
+        </p:txBody>
+      </p:sp>
+      <p:sp>
+        <p:nvSpPr>
+          <p:cNvPr id="13" name="Rectangle 12"/>
+          <p:cNvSpPr/>
+          <p:nvPr/>
+        </p:nvSpPr>
+        <p:spPr>
+          <a:xfrm>
+            <a:off x="640080" y="1024128"/>
+            <a:ext cx="1463040" cy="301752"/>
+          </a:xfrm>
+          <a:prstGeom prst="rect">
+            <a:avLst/>
+          </a:prstGeom>
+          <a:solidFill>
+            <a:srgbClr val="8C8C8C"/>
+          </a:solidFill>
+          <a:ln>
+            <a:noFill/>
+          </a:ln>
+          <a:effectLst/>
+        </p:spPr>
+        <p:style>
+          <a:lnRef idx="1">
+            <a:schemeClr val="accent1"/>
+          </a:lnRef>
+          <a:fillRef idx="3">
+            <a:schemeClr val="accent1"/>
+          </a:fillRef>
+          <a:effectRef idx="2">
+            <a:schemeClr val="accent1"/>
+          </a:effectRef>
+          <a:fontRef idx="minor">
+            <a:schemeClr val="lt1"/>
+          </a:fontRef>
+        </p:style>
+        <p:txBody>
+          <a:bodyPr rtlCol="0" anchor="ctr" wrap="square" lIns="36576" rIns="36576" tIns="0" bIns="0"/>
+          <a:lstStyle/>
+          <a:p>
+            <a:pPr algn="ctr"/>
+            <a:r>
+              <a:rPr sz="1100" b="1" i="0">
+                <a:solidFill>
+                  <a:srgbClr val="FFFFFF"/>
+                </a:solidFill>
+                <a:latin typeface="Malgun Gothic"/>
+              </a:rPr>
+              <a:t>Phase 1 ~ 5</a:t>
+            </a:r>
+          </a:p>
+        </p:txBody>
+      </p:sp>
+      <p:sp>
+        <p:nvSpPr>
+          <p:cNvPr id="14" name="TextBox 13"/>
+          <p:cNvSpPr txBox="1"/>
+          <p:nvPr/>
+        </p:nvSpPr>
+        <p:spPr>
+          <a:xfrm>
+            <a:off x="2240280" y="1051560"/>
+            <a:ext cx="9326880" cy="274320"/>
+          </a:xfrm>
+          <a:prstGeom prst="rect">
+            <a:avLst/>
+          </a:prstGeom>
+          <a:noFill/>
+        </p:spPr>
+        <p:txBody>
+          <a:bodyPr wrap="square" lIns="36576" rIns="36576" tIns="0" bIns="0">
+            <a:spAutoFit/>
+          </a:bodyPr>
+          <a:lstStyle/>
+          <a:p>
+            <a:pPr algn="l">
+              <a:spcAft>
+                <a:spcPts val="400"/>
+              </a:spcAft>
+            </a:pPr>
+            <a:r>
+              <a:rPr sz="1200" b="0" i="0">
+                <a:solidFill>
+                  <a:srgbClr val="5D6D7E"/>
+                </a:solidFill>
+                <a:latin typeface="Malgun Gothic"/>
+              </a:rPr>
+              <a:t>새 기능을 붙이는 작업이 아니다. 판정이 흔들리는 구조적 원인을 걷어낸다.</a:t>
+            </a:r>
+          </a:p>
+        </p:txBody>
+      </p:sp>
+      <p:graphicFrame>
+        <p:nvGraphicFramePr>
+          <p:cNvPr id="15" name="Table 14"/>
+          <p:cNvGraphicFramePr>
+            <a:graphicFrameLocks noGrp="1"/>
+          </p:cNvGraphicFramePr>
+          <p:nvPr/>
+        </p:nvGraphicFramePr>
+        <p:xfrm>
+          <a:off x="658368" y="1481328"/>
+          <a:ext cx="11064240" cy="2706624"/>
+        </p:xfrm>
+        <a:graphic>
+          <a:graphicData uri="http://schemas.openxmlformats.org/drawingml/2006/table">
+            <a:tbl>
+              <a:tblPr firstRow="1" bandRow="0">
+                <a:tableStyleId>{5C22544A-7EE6-4342-B048-85BDC9FD1C3A}</a:tableStyleId>
+              </a:tblPr>
+              <a:tblGrid>
+                <a:gridCol w="685800"/>
+                <a:gridCol w="3794760"/>
+                <a:gridCol w="5394960"/>
+                <a:gridCol w="1188720"/>
+              </a:tblGrid>
+              <a:tr h="329184">
+                <a:tc>
+                  <a:txBody>
+                    <a:bodyPr/>
+                    <a:lstStyle/>
+                    <a:p>
+                      <a:pPr algn="ctr"/>
+                      <a:r>
+                        <a:rPr sz="1100" b="1" i="0">
+                          <a:solidFill>
+                            <a:srgbClr val="FFFFFF"/>
+                          </a:solidFill>
+                          <a:latin typeface="Malgun Gothic"/>
+                        </a:rPr>
+                        <a:t>단계</a:t>
+                      </a:r>
+                    </a:p>
+                  </a:txBody>
+                  <a:tcPr marL="73152" marR="73152" marT="0" marB="0" anchor="ctr">
+                    <a:lnB w="9525" cap="flat" cmpd="sng" algn="ctr">
+                      <a:solidFill>
+                        <a:srgbClr val="333B45"/>
+                      </a:solidFill>
+                    </a:lnB>
+                    <a:lnT w="9525" cap="flat" cmpd="sng" algn="ctr">
+                      <a:solidFill>
+                        <a:srgbClr val="333B45"/>
+                      </a:solidFill>
+                    </a:lnT>
+                    <a:lnR w="9525" cap="flat" cmpd="sng" algn="ctr">
+                      <a:solidFill>
+                        <a:srgbClr val="333B45"/>
+                      </a:solidFill>
+                    </a:lnR>
+                    <a:lnL w="9525" cap="flat" cmpd="sng" algn="ctr">
+                      <a:solidFill>
+                        <a:srgbClr val="333B45"/>
+                      </a:solidFill>
+                    </a:lnL>
+                    <a:solidFill>
+                      <a:srgbClr val="333B45"/>
+                    </a:solidFill>
+                  </a:tcPr>
+                </a:tc>
+                <a:tc>
+                  <a:txBody>
+                    <a:bodyPr/>
+                    <a:lstStyle/>
+                    <a:p>
+                      <a:pPr algn="ctr"/>
+                      <a:r>
+                        <a:rPr sz="1100" b="1" i="0">
+                          <a:solidFill>
+                            <a:srgbClr val="FFFFFF"/>
+                          </a:solidFill>
+                          <a:latin typeface="Malgun Gothic"/>
+                        </a:rPr>
+                        <a:t>무엇을 하는가</a:t>
+                      </a:r>
+                    </a:p>
+                  </a:txBody>
+                  <a:tcPr marL="73152" marR="73152" marT="0" marB="0" anchor="ctr">
+                    <a:lnB w="9525" cap="flat" cmpd="sng" algn="ctr">
+                      <a:solidFill>
+                        <a:srgbClr val="333B45"/>
+                      </a:solidFill>
+                    </a:lnB>
+                    <a:lnT w="9525" cap="flat" cmpd="sng" algn="ctr">
+                      <a:solidFill>
+                        <a:srgbClr val="333B45"/>
+                      </a:solidFill>
+                    </a:lnT>
+                    <a:lnR w="9525" cap="flat" cmpd="sng" algn="ctr">
+                      <a:solidFill>
+                        <a:srgbClr val="333B45"/>
+                      </a:solidFill>
+                    </a:lnR>
+                    <a:lnL w="9525" cap="flat" cmpd="sng" algn="ctr">
+                      <a:solidFill>
+                        <a:srgbClr val="333B45"/>
+                      </a:solidFill>
+                    </a:lnL>
+                    <a:solidFill>
+                      <a:srgbClr val="333B45"/>
+                    </a:solidFill>
+                  </a:tcPr>
+                </a:tc>
+                <a:tc>
+                  <a:txBody>
+                    <a:bodyPr/>
+                    <a:lstStyle/>
+                    <a:p>
+                      <a:pPr algn="ctr"/>
+                      <a:r>
+                        <a:rPr sz="1100" b="1" i="0">
+                          <a:solidFill>
+                            <a:srgbClr val="FFFFFF"/>
+                          </a:solidFill>
+                          <a:latin typeface="Malgun Gothic"/>
+                        </a:rPr>
+                        <a:t>출하 시 현장에서 확인할 것</a:t>
+                      </a:r>
+                    </a:p>
+                  </a:txBody>
+                  <a:tcPr marL="73152" marR="73152" marT="0" marB="0" anchor="ctr">
+                    <a:lnB w="9525" cap="flat" cmpd="sng" algn="ctr">
+                      <a:solidFill>
+                        <a:srgbClr val="333B45"/>
+                      </a:solidFill>
+                    </a:lnB>
+                    <a:lnT w="9525" cap="flat" cmpd="sng" algn="ctr">
+                      <a:solidFill>
+                        <a:srgbClr val="333B45"/>
+                      </a:solidFill>
+                    </a:lnT>
+                    <a:lnR w="9525" cap="flat" cmpd="sng" algn="ctr">
+                      <a:solidFill>
+                        <a:srgbClr val="333B45"/>
+                      </a:solidFill>
+                    </a:lnR>
+                    <a:lnL w="9525" cap="flat" cmpd="sng" algn="ctr">
+                      <a:solidFill>
+                        <a:srgbClr val="333B45"/>
+                      </a:solidFill>
+                    </a:lnL>
+                    <a:solidFill>
+                      <a:srgbClr val="333B45"/>
+                    </a:solidFill>
+                  </a:tcPr>
+                </a:tc>
+                <a:tc>
+                  <a:txBody>
+                    <a:bodyPr/>
+                    <a:lstStyle/>
+                    <a:p>
+                      <a:pPr algn="ctr"/>
+                      <a:r>
+                        <a:rPr sz="1100" b="1" i="0">
+                          <a:solidFill>
+                            <a:srgbClr val="FFFFFF"/>
+                          </a:solidFill>
+                          <a:latin typeface="Malgun Gothic"/>
+                        </a:rPr>
+                        <a:t>상태</a:t>
+                      </a:r>
+                    </a:p>
+                  </a:txBody>
+                  <a:tcPr marL="73152" marR="73152" marT="0" marB="0" anchor="ctr">
+                    <a:lnB w="9525" cap="flat" cmpd="sng" algn="ctr">
+                      <a:solidFill>
+                        <a:srgbClr val="333B45"/>
+                      </a:solidFill>
+                    </a:lnB>
+                    <a:lnT w="9525" cap="flat" cmpd="sng" algn="ctr">
+                      <a:solidFill>
+                        <a:srgbClr val="333B45"/>
+                      </a:solidFill>
+                    </a:lnT>
+                    <a:lnR w="9525" cap="flat" cmpd="sng" algn="ctr">
+                      <a:solidFill>
+                        <a:srgbClr val="333B45"/>
+                      </a:solidFill>
+                    </a:lnR>
+                    <a:lnL w="9525" cap="flat" cmpd="sng" algn="ctr">
+                      <a:solidFill>
+                        <a:srgbClr val="333B45"/>
+                      </a:solidFill>
+                    </a:lnL>
+                    <a:solidFill>
+                      <a:srgbClr val="333B45"/>
+                    </a:solidFill>
+                  </a:tcPr>
+                </a:tc>
+              </a:tr>
+              <a:tr h="475488">
+                <a:tc>
+                  <a:txBody>
+                    <a:bodyPr/>
+                    <a:lstStyle/>
+                    <a:p>
+                      <a:pPr algn="ctr"/>
+                      <a:r>
+                        <a:rPr sz="1150" b="1" i="0">
+                          <a:solidFill>
+                            <a:srgbClr val="1C2833"/>
+                          </a:solidFill>
+                          <a:latin typeface="Malgun Gothic"/>
+                        </a:rPr>
+                        <a:t>1</a:t>
+                      </a:r>
+                    </a:p>
+                  </a:txBody>
+                  <a:tcPr marL="73152" marR="73152" marT="18288" marB="18288" anchor="ctr">
+                    <a:lnB w="9525" cap="flat" cmpd="sng" algn="ctr">
+                      <a:solidFill>
+                        <a:srgbClr val="D5DBDB"/>
+                      </a:solidFill>
+                    </a:lnB>
+                    <a:lnT w="9525" cap="flat" cmpd="sng" algn="ctr">
+                      <a:solidFill>
+                        <a:srgbClr val="FFFFFF"/>
+                      </a:solidFill>
+                    </a:lnT>
+                    <a:lnR w="9525" cap="flat" cmpd="sng" algn="ctr">
+                      <a:solidFill>
+                        <a:srgbClr val="FFFFFF"/>
+                      </a:solidFill>
+                    </a:lnR>
+                    <a:lnL w="9525" cap="flat" cmpd="sng" algn="ctr">
+                      <a:solidFill>
+                        <a:srgbClr val="FFFFFF"/>
+                      </a:solidFill>
+                    </a:lnL>
+                    <a:solidFill>
+                      <a:srgbClr val="FFFFFF"/>
+                    </a:solidFill>
+                  </a:tcPr>
+                </a:tc>
+                <a:tc>
+                  <a:txBody>
+                    <a:bodyPr/>
+                    <a:lstStyle/>
+                    <a:p>
+                      <a:pPr algn="l"/>
+                      <a:r>
+                        <a:rPr sz="1150" b="0" i="0">
+                          <a:solidFill>
+                            <a:srgbClr val="1C2833"/>
+                          </a:solidFill>
+                          <a:latin typeface="Malgun Gothic"/>
+                        </a:rPr>
+                        <a:t>테스트 하네스와 CI 회귀 게이트</a:t>
+                      </a:r>
+                    </a:p>
+                  </a:txBody>
+                  <a:tcPr marL="73152" marR="73152" marT="18288" marB="18288" anchor="ctr">
+                    <a:lnB w="9525" cap="flat" cmpd="sng" algn="ctr">
+                      <a:solidFill>
+                        <a:srgbClr val="D5DBDB"/>
+                      </a:solidFill>
+                    </a:lnB>
+                    <a:lnT w="9525" cap="flat" cmpd="sng" algn="ctr">
+                      <a:solidFill>
+                        <a:srgbClr val="FFFFFF"/>
+                      </a:solidFill>
+                    </a:lnT>
+                    <a:lnR w="9525" cap="flat" cmpd="sng" algn="ctr">
+                      <a:solidFill>
+                        <a:srgbClr val="FFFFFF"/>
+                      </a:solidFill>
+                    </a:lnR>
+                    <a:lnL w="9525" cap="flat" cmpd="sng" algn="ctr">
+                      <a:solidFill>
+                        <a:srgbClr val="FFFFFF"/>
+                      </a:solidFill>
+                    </a:lnL>
+                    <a:solidFill>
+                      <a:srgbClr val="FFFFFF"/>
+                    </a:solidFill>
+                  </a:tcPr>
+                </a:tc>
+                <a:tc>
+                  <a:txBody>
+                    <a:bodyPr/>
+                    <a:lstStyle/>
+                    <a:p>
+                      <a:pPr algn="l"/>
+                      <a:r>
+                        <a:rPr sz="1150" b="0" i="0">
+                          <a:solidFill>
+                            <a:srgbClr val="1C2833"/>
+                          </a:solidFill>
+                          <a:latin typeface="Malgun Gothic"/>
+                        </a:rPr>
+                        <a:t>설치 · 경보 동작이 이전과 같은가</a:t>
+                      </a:r>
+                    </a:p>
+                  </a:txBody>
+                  <a:tcPr marL="73152" marR="73152" marT="18288" marB="18288" anchor="ctr">
+                    <a:lnB w="9525" cap="flat" cmpd="sng" algn="ctr">
+                      <a:solidFill>
+                        <a:srgbClr val="D5DBDB"/>
+                      </a:solidFill>
+                    </a:lnB>
+                    <a:lnT w="9525" cap="flat" cmpd="sng" algn="ctr">
+                      <a:solidFill>
+                        <a:srgbClr val="FFFFFF"/>
+                      </a:solidFill>
+                    </a:lnT>
+                    <a:lnR w="9525" cap="flat" cmpd="sng" algn="ctr">
+                      <a:solidFill>
+                        <a:srgbClr val="FFFFFF"/>
+                      </a:solidFill>
+                    </a:lnR>
+                    <a:lnL w="9525" cap="flat" cmpd="sng" algn="ctr">
+                      <a:solidFill>
+                        <a:srgbClr val="FFFFFF"/>
+                      </a:solidFill>
+                    </a:lnL>
+                    <a:solidFill>
+                      <a:srgbClr val="FFFFFF"/>
+                    </a:solidFill>
+                  </a:tcPr>
+                </a:tc>
+                <a:tc>
+                  <a:txBody>
+                    <a:bodyPr/>
+                    <a:lstStyle/>
+                    <a:p>
+                      <a:pPr algn="ctr"/>
+                      <a:r>
+                        <a:rPr sz="1150" b="0" i="0">
+                          <a:solidFill>
+                            <a:srgbClr val="1C2833"/>
+                          </a:solidFill>
+                          <a:latin typeface="Malgun Gothic"/>
+                        </a:rPr>
+                        <a:t>완료</a:t>
+                      </a:r>
+                    </a:p>
+                  </a:txBody>
+                  <a:tcPr marL="73152" marR="73152" marT="18288" marB="18288" anchor="ctr">
+                    <a:lnB w="9525" cap="flat" cmpd="sng" algn="ctr">
+                      <a:solidFill>
+                        <a:srgbClr val="D5DBDB"/>
+                      </a:solidFill>
+                    </a:lnB>
+                    <a:lnT w="9525" cap="flat" cmpd="sng" algn="ctr">
+                      <a:solidFill>
+                        <a:srgbClr val="FFFFFF"/>
+                      </a:solidFill>
+                    </a:lnT>
+                    <a:lnR w="9525" cap="flat" cmpd="sng" algn="ctr">
+                      <a:solidFill>
+                        <a:srgbClr val="FFFFFF"/>
+                      </a:solidFill>
+                    </a:lnR>
+                    <a:lnL w="9525" cap="flat" cmpd="sng" algn="ctr">
+                      <a:solidFill>
+                        <a:srgbClr val="FFFFFF"/>
+                      </a:solidFill>
+                    </a:lnL>
+                    <a:solidFill>
+                      <a:srgbClr val="FFFFFF"/>
+                    </a:solidFill>
+                  </a:tcPr>
+                </a:tc>
+              </a:tr>
+              <a:tr h="475488">
+                <a:tc>
+                  <a:txBody>
+                    <a:bodyPr/>
+                    <a:lstStyle/>
+                    <a:p>
+                      <a:pPr algn="ctr"/>
+                      <a:r>
+                        <a:rPr sz="1150" b="1" i="0">
+                          <a:solidFill>
+                            <a:srgbClr val="1C2833"/>
+                          </a:solidFill>
+                          <a:latin typeface="Malgun Gothic"/>
+                        </a:rPr>
+                        <a:t>2</a:t>
+                      </a:r>
+                    </a:p>
+                  </a:txBody>
+                  <a:tcPr marL="73152" marR="73152" marT="18288" marB="18288" anchor="ctr">
+                    <a:lnB w="9525" cap="flat" cmpd="sng" algn="ctr">
+                      <a:solidFill>
+                        <a:srgbClr val="D5DBDB"/>
+                      </a:solidFill>
+                    </a:lnB>
+                    <a:lnT w="9525" cap="flat" cmpd="sng" algn="ctr">
+                      <a:solidFill>
+                        <a:srgbClr val="FFFFFF"/>
+                      </a:solidFill>
+                    </a:lnT>
+                    <a:lnR w="9525" cap="flat" cmpd="sng" algn="ctr">
+                      <a:solidFill>
+                        <a:srgbClr val="FFFFFF"/>
+                      </a:solidFill>
+                    </a:lnR>
+                    <a:lnL w="9525" cap="flat" cmpd="sng" algn="ctr">
+                      <a:solidFill>
+                        <a:srgbClr val="FFFFFF"/>
+                      </a:solidFill>
+                    </a:lnL>
+                    <a:solidFill>
+                      <a:srgbClr val="FFFFFF"/>
+                    </a:solidFill>
+                  </a:tcPr>
+                </a:tc>
+                <a:tc>
+                  <a:txBody>
+                    <a:bodyPr/>
+                    <a:lstStyle/>
+                    <a:p>
+                      <a:pPr algn="l"/>
+                      <a:r>
+                        <a:rPr sz="1150" b="0" i="0">
+                          <a:solidFill>
+                            <a:srgbClr val="1C2833"/>
+                          </a:solidFill>
+                          <a:latin typeface="Malgun Gothic"/>
+                        </a:rPr>
+                        <a:t>안전 크리티컬 경로 골든 테스트</a:t>
+                      </a:r>
+                    </a:p>
+                  </a:txBody>
+                  <a:tcPr marL="73152" marR="73152" marT="18288" marB="18288" anchor="ctr">
+                    <a:lnB w="9525" cap="flat" cmpd="sng" algn="ctr">
+                      <a:solidFill>
+                        <a:srgbClr val="D5DBDB"/>
+                      </a:solidFill>
+                    </a:lnB>
+                    <a:lnT w="9525" cap="flat" cmpd="sng" algn="ctr">
+                      <a:solidFill>
+                        <a:srgbClr val="FFFFFF"/>
+                      </a:solidFill>
+                    </a:lnT>
+                    <a:lnR w="9525" cap="flat" cmpd="sng" algn="ctr">
+                      <a:solidFill>
+                        <a:srgbClr val="FFFFFF"/>
+                      </a:solidFill>
+                    </a:lnR>
+                    <a:lnL w="9525" cap="flat" cmpd="sng" algn="ctr">
+                      <a:solidFill>
+                        <a:srgbClr val="FFFFFF"/>
+                      </a:solidFill>
+                    </a:lnL>
+                    <a:solidFill>
+                      <a:srgbClr val="FFFFFF"/>
+                    </a:solidFill>
+                  </a:tcPr>
+                </a:tc>
+                <a:tc>
+                  <a:txBody>
+                    <a:bodyPr/>
+                    <a:lstStyle/>
+                    <a:p>
+                      <a:pPr algn="l"/>
+                      <a:r>
+                        <a:rPr sz="1150" b="0" i="0">
+                          <a:solidFill>
+                            <a:srgbClr val="1C2833"/>
+                          </a:solidFill>
+                          <a:latin typeface="Malgun Gothic"/>
+                        </a:rPr>
+                        <a:t>천천히 접근하는 지게차에 경고가 뜨는가</a:t>
+                      </a:r>
+                    </a:p>
+                  </a:txBody>
+                  <a:tcPr marL="73152" marR="73152" marT="18288" marB="18288" anchor="ctr">
+                    <a:lnB w="9525" cap="flat" cmpd="sng" algn="ctr">
+                      <a:solidFill>
+                        <a:srgbClr val="D5DBDB"/>
+                      </a:solidFill>
+                    </a:lnB>
+                    <a:lnT w="9525" cap="flat" cmpd="sng" algn="ctr">
+                      <a:solidFill>
+                        <a:srgbClr val="FFFFFF"/>
+                      </a:solidFill>
+                    </a:lnT>
+                    <a:lnR w="9525" cap="flat" cmpd="sng" algn="ctr">
+                      <a:solidFill>
+                        <a:srgbClr val="FFFFFF"/>
+                      </a:solidFill>
+                    </a:lnR>
+                    <a:lnL w="9525" cap="flat" cmpd="sng" algn="ctr">
+                      <a:solidFill>
+                        <a:srgbClr val="FFFFFF"/>
+                      </a:solidFill>
+                    </a:lnL>
+                    <a:solidFill>
+                      <a:srgbClr val="FFFFFF"/>
+                    </a:solidFill>
+                  </a:tcPr>
+                </a:tc>
+                <a:tc>
+                  <a:txBody>
+                    <a:bodyPr/>
+                    <a:lstStyle/>
+                    <a:p>
+                      <a:pPr algn="ctr"/>
+                      <a:r>
+                        <a:rPr sz="1150" b="0" i="0">
+                          <a:solidFill>
+                            <a:srgbClr val="1C2833"/>
+                          </a:solidFill>
+                          <a:latin typeface="Malgun Gothic"/>
+                        </a:rPr>
+                        <a:t>예정</a:t>
+                      </a:r>
+                    </a:p>
+                  </a:txBody>
+                  <a:tcPr marL="73152" marR="73152" marT="18288" marB="18288" anchor="ctr">
+                    <a:lnB w="9525" cap="flat" cmpd="sng" algn="ctr">
+                      <a:solidFill>
+                        <a:srgbClr val="D5DBDB"/>
+                      </a:solidFill>
+                    </a:lnB>
+                    <a:lnT w="9525" cap="flat" cmpd="sng" algn="ctr">
+                      <a:solidFill>
+                        <a:srgbClr val="FFFFFF"/>
+                      </a:solidFill>
+                    </a:lnT>
+                    <a:lnR w="9525" cap="flat" cmpd="sng" algn="ctr">
+                      <a:solidFill>
+                        <a:srgbClr val="FFFFFF"/>
+                      </a:solidFill>
+                    </a:lnR>
+                    <a:lnL w="9525" cap="flat" cmpd="sng" algn="ctr">
+                      <a:solidFill>
+                        <a:srgbClr val="FFFFFF"/>
+                      </a:solidFill>
+                    </a:lnL>
+                    <a:solidFill>
+                      <a:srgbClr val="FFFFFF"/>
+                    </a:solidFill>
+                  </a:tcPr>
+                </a:tc>
+              </a:tr>
+              <a:tr h="475488">
+                <a:tc>
+                  <a:txBody>
+                    <a:bodyPr/>
+                    <a:lstStyle/>
+                    <a:p>
+                      <a:pPr algn="ctr"/>
+                      <a:r>
+                        <a:rPr sz="1150" b="1" i="0">
+                          <a:solidFill>
+                            <a:srgbClr val="1C2833"/>
+                          </a:solidFill>
+                          <a:latin typeface="Malgun Gothic"/>
+                        </a:rPr>
+                        <a:t>3</a:t>
+                      </a:r>
+                    </a:p>
+                  </a:txBody>
+                  <a:tcPr marL="73152" marR="73152" marT="18288" marB="18288" anchor="ctr">
+                    <a:lnB w="9525" cap="flat" cmpd="sng" algn="ctr">
+                      <a:solidFill>
+                        <a:srgbClr val="D5DBDB"/>
+                      </a:solidFill>
+                    </a:lnB>
+                    <a:lnT w="9525" cap="flat" cmpd="sng" algn="ctr">
+                      <a:solidFill>
+                        <a:srgbClr val="FFFFFF"/>
+                      </a:solidFill>
+                    </a:lnT>
+                    <a:lnR w="9525" cap="flat" cmpd="sng" algn="ctr">
+                      <a:solidFill>
+                        <a:srgbClr val="FFFFFF"/>
+                      </a:solidFill>
+                    </a:lnR>
+                    <a:lnL w="9525" cap="flat" cmpd="sng" algn="ctr">
+                      <a:solidFill>
+                        <a:srgbClr val="FFFFFF"/>
+                      </a:solidFill>
+                    </a:lnL>
+                    <a:solidFill>
+                      <a:srgbClr val="FFFFFF"/>
+                    </a:solidFill>
+                  </a:tcPr>
+                </a:tc>
+                <a:tc>
+                  <a:txBody>
+                    <a:bodyPr/>
+                    <a:lstStyle/>
+                    <a:p>
+                      <a:pPr algn="l"/>
+                      <a:r>
+                        <a:rPr sz="1150" b="0" i="0">
+                          <a:solidFill>
+                            <a:srgbClr val="1C2833"/>
+                          </a:solidFill>
+                          <a:latin typeface="Malgun Gothic"/>
+                        </a:rPr>
+                        <a:t>BleService 분해</a:t>
+                      </a:r>
+                    </a:p>
+                  </a:txBody>
+                  <a:tcPr marL="73152" marR="73152" marT="18288" marB="18288" anchor="ctr">
+                    <a:lnB w="9525" cap="flat" cmpd="sng" algn="ctr">
+                      <a:solidFill>
+                        <a:srgbClr val="D5DBDB"/>
+                      </a:solidFill>
+                    </a:lnB>
+                    <a:lnT w="9525" cap="flat" cmpd="sng" algn="ctr">
+                      <a:solidFill>
+                        <a:srgbClr val="FFFFFF"/>
+                      </a:solidFill>
+                    </a:lnT>
+                    <a:lnR w="9525" cap="flat" cmpd="sng" algn="ctr">
+                      <a:solidFill>
+                        <a:srgbClr val="FFFFFF"/>
+                      </a:solidFill>
+                    </a:lnR>
+                    <a:lnL w="9525" cap="flat" cmpd="sng" algn="ctr">
+                      <a:solidFill>
+                        <a:srgbClr val="FFFFFF"/>
+                      </a:solidFill>
+                    </a:lnL>
+                    <a:solidFill>
+                      <a:srgbClr val="FFFFFF"/>
+                    </a:solidFill>
+                  </a:tcPr>
+                </a:tc>
+                <a:tc>
+                  <a:txBody>
+                    <a:bodyPr/>
+                    <a:lstStyle/>
+                    <a:p>
+                      <a:pPr algn="l"/>
+                      <a:r>
+                        <a:rPr sz="1150" b="0" i="0">
+                          <a:solidFill>
+                            <a:srgbClr val="1C2833"/>
+                          </a:solidFill>
+                          <a:latin typeface="Malgun Gothic"/>
+                        </a:rPr>
+                        <a:t>달라진 게 없는가 (동작 보존)</a:t>
+                      </a:r>
+                    </a:p>
+                  </a:txBody>
+                  <a:tcPr marL="73152" marR="73152" marT="18288" marB="18288" anchor="ctr">
+                    <a:lnB w="9525" cap="flat" cmpd="sng" algn="ctr">
+                      <a:solidFill>
+                        <a:srgbClr val="D5DBDB"/>
+                      </a:solidFill>
+                    </a:lnB>
+                    <a:lnT w="9525" cap="flat" cmpd="sng" algn="ctr">
+                      <a:solidFill>
+                        <a:srgbClr val="FFFFFF"/>
+                      </a:solidFill>
+                    </a:lnT>
+                    <a:lnR w="9525" cap="flat" cmpd="sng" algn="ctr">
+                      <a:solidFill>
+                        <a:srgbClr val="FFFFFF"/>
+                      </a:solidFill>
+                    </a:lnR>
+                    <a:lnL w="9525" cap="flat" cmpd="sng" algn="ctr">
+                      <a:solidFill>
+                        <a:srgbClr val="FFFFFF"/>
+                      </a:solidFill>
+                    </a:lnL>
+                    <a:solidFill>
+                      <a:srgbClr val="FFFFFF"/>
+                    </a:solidFill>
+                  </a:tcPr>
+                </a:tc>
+                <a:tc>
+                  <a:txBody>
+                    <a:bodyPr/>
+                    <a:lstStyle/>
+                    <a:p>
+                      <a:pPr algn="ctr"/>
+                      <a:r>
+                        <a:rPr sz="1150" b="0" i="0">
+                          <a:solidFill>
+                            <a:srgbClr val="1C2833"/>
+                          </a:solidFill>
+                          <a:latin typeface="Malgun Gothic"/>
+                        </a:rPr>
+                        <a:t>예정</a:t>
+                      </a:r>
+                    </a:p>
+                  </a:txBody>
+                  <a:tcPr marL="73152" marR="73152" marT="18288" marB="18288" anchor="ctr">
+                    <a:lnB w="9525" cap="flat" cmpd="sng" algn="ctr">
+                      <a:solidFill>
+                        <a:srgbClr val="D5DBDB"/>
+                      </a:solidFill>
+                    </a:lnB>
+                    <a:lnT w="9525" cap="flat" cmpd="sng" algn="ctr">
+                      <a:solidFill>
+                        <a:srgbClr val="FFFFFF"/>
+                      </a:solidFill>
+                    </a:lnT>
+                    <a:lnR w="9525" cap="flat" cmpd="sng" algn="ctr">
+                      <a:solidFill>
+                        <a:srgbClr val="FFFFFF"/>
+                      </a:solidFill>
+                    </a:lnR>
+                    <a:lnL w="9525" cap="flat" cmpd="sng" algn="ctr">
+                      <a:solidFill>
+                        <a:srgbClr val="FFFFFF"/>
+                      </a:solidFill>
+                    </a:lnL>
+                    <a:solidFill>
+                      <a:srgbClr val="FFFFFF"/>
+                    </a:solidFill>
+                  </a:tcPr>
+                </a:tc>
+              </a:tr>
+              <a:tr h="475488">
+                <a:tc>
+                  <a:txBody>
+                    <a:bodyPr/>
+                    <a:lstStyle/>
+                    <a:p>
+                      <a:pPr algn="ctr"/>
+                      <a:r>
+                        <a:rPr sz="1150" b="1" i="0">
+                          <a:solidFill>
+                            <a:srgbClr val="1C2833"/>
+                          </a:solidFill>
+                          <a:latin typeface="Malgun Gothic"/>
+                        </a:rPr>
+                        <a:t>4</a:t>
+                      </a:r>
+                    </a:p>
+                  </a:txBody>
+                  <a:tcPr marL="73152" marR="73152" marT="18288" marB="18288" anchor="ctr">
+                    <a:lnB w="9525" cap="flat" cmpd="sng" algn="ctr">
+                      <a:solidFill>
+                        <a:srgbClr val="D5DBDB"/>
+                      </a:solidFill>
+                    </a:lnB>
+                    <a:lnT w="9525" cap="flat" cmpd="sng" algn="ctr">
+                      <a:solidFill>
+                        <a:srgbClr val="FFFFFF"/>
+                      </a:solidFill>
+                    </a:lnT>
+                    <a:lnR w="9525" cap="flat" cmpd="sng" algn="ctr">
+                      <a:solidFill>
+                        <a:srgbClr val="FFFFFF"/>
+                      </a:solidFill>
+                    </a:lnR>
+                    <a:lnL w="9525" cap="flat" cmpd="sng" algn="ctr">
+                      <a:solidFill>
+                        <a:srgbClr val="FFFFFF"/>
+                      </a:solidFill>
+                    </a:lnL>
+                    <a:solidFill>
+                      <a:srgbClr val="FFFFFF"/>
+                    </a:solidFill>
+                  </a:tcPr>
+                </a:tc>
+                <a:tc>
+                  <a:txBody>
+                    <a:bodyPr/>
+                    <a:lstStyle/>
+                    <a:p>
+                      <a:pPr algn="l"/>
+                      <a:r>
+                        <a:rPr sz="1150" b="0" i="0">
+                          <a:solidFill>
+                            <a:srgbClr val="1C2833"/>
+                          </a:solidFill>
+                          <a:latin typeface="Malgun Gothic"/>
+                        </a:rPr>
+                        <a:t>기기 상태 단일화</a:t>
+                      </a:r>
+                    </a:p>
+                  </a:txBody>
+                  <a:tcPr marL="73152" marR="73152" marT="18288" marB="18288" anchor="ctr">
+                    <a:lnB w="9525" cap="flat" cmpd="sng" algn="ctr">
+                      <a:solidFill>
+                        <a:srgbClr val="D5DBDB"/>
+                      </a:solidFill>
+                    </a:lnB>
+                    <a:lnT w="9525" cap="flat" cmpd="sng" algn="ctr">
+                      <a:solidFill>
+                        <a:srgbClr val="FFFFFF"/>
+                      </a:solidFill>
+                    </a:lnT>
+                    <a:lnR w="9525" cap="flat" cmpd="sng" algn="ctr">
+                      <a:solidFill>
+                        <a:srgbClr val="FFFFFF"/>
+                      </a:solidFill>
+                    </a:lnR>
+                    <a:lnL w="9525" cap="flat" cmpd="sng" algn="ctr">
+                      <a:solidFill>
+                        <a:srgbClr val="FFFFFF"/>
+                      </a:solidFill>
+                    </a:lnL>
+                    <a:solidFill>
+                      <a:srgbClr val="FFFFFF"/>
+                    </a:solidFill>
+                  </a:tcPr>
+                </a:tc>
+                <a:tc>
+                  <a:txBody>
+                    <a:bodyPr/>
+                    <a:lstStyle/>
+                    <a:p>
+                      <a:pPr algn="l"/>
+                      <a:r>
+                        <a:rPr sz="1150" b="0" i="0">
+                          <a:solidFill>
+                            <a:srgbClr val="1C2833"/>
+                          </a:solidFill>
+                          <a:latin typeface="Malgun Gothic"/>
+                        </a:rPr>
+                        <a:t>2시간 이상 구동 후에도 느려지지 않는가</a:t>
+                      </a:r>
+                    </a:p>
+                  </a:txBody>
+                  <a:tcPr marL="73152" marR="73152" marT="18288" marB="18288" anchor="ctr">
+                    <a:lnB w="9525" cap="flat" cmpd="sng" algn="ctr">
+                      <a:solidFill>
+                        <a:srgbClr val="D5DBDB"/>
+                      </a:solidFill>
+                    </a:lnB>
+                    <a:lnT w="9525" cap="flat" cmpd="sng" algn="ctr">
+                      <a:solidFill>
+                        <a:srgbClr val="FFFFFF"/>
+                      </a:solidFill>
+                    </a:lnT>
+                    <a:lnR w="9525" cap="flat" cmpd="sng" algn="ctr">
+                      <a:solidFill>
+                        <a:srgbClr val="FFFFFF"/>
+                      </a:solidFill>
+                    </a:lnR>
+                    <a:lnL w="9525" cap="flat" cmpd="sng" algn="ctr">
+                      <a:solidFill>
+                        <a:srgbClr val="FFFFFF"/>
+                      </a:solidFill>
+                    </a:lnL>
+                    <a:solidFill>
+                      <a:srgbClr val="FFFFFF"/>
+                    </a:solidFill>
+                  </a:tcPr>
+                </a:tc>
+                <a:tc>
+                  <a:txBody>
+                    <a:bodyPr/>
+                    <a:lstStyle/>
+                    <a:p>
+                      <a:pPr algn="ctr"/>
+                      <a:r>
+                        <a:rPr sz="1150" b="0" i="0">
+                          <a:solidFill>
+                            <a:srgbClr val="1C2833"/>
+                          </a:solidFill>
+                          <a:latin typeface="Malgun Gothic"/>
+                        </a:rPr>
+                        <a:t>예정</a:t>
+                      </a:r>
+                    </a:p>
+                  </a:txBody>
+                  <a:tcPr marL="73152" marR="73152" marT="18288" marB="18288" anchor="ctr">
+                    <a:lnB w="9525" cap="flat" cmpd="sng" algn="ctr">
+                      <a:solidFill>
+                        <a:srgbClr val="D5DBDB"/>
+                      </a:solidFill>
+                    </a:lnB>
+                    <a:lnT w="9525" cap="flat" cmpd="sng" algn="ctr">
+                      <a:solidFill>
+                        <a:srgbClr val="FFFFFF"/>
+                      </a:solidFill>
+                    </a:lnT>
+                    <a:lnR w="9525" cap="flat" cmpd="sng" algn="ctr">
+                      <a:solidFill>
+                        <a:srgbClr val="FFFFFF"/>
+                      </a:solidFill>
+                    </a:lnR>
+                    <a:lnL w="9525" cap="flat" cmpd="sng" algn="ctr">
+                      <a:solidFill>
+                        <a:srgbClr val="FFFFFF"/>
+                      </a:solidFill>
+                    </a:lnL>
+                    <a:solidFill>
+                      <a:srgbClr val="FFFFFF"/>
+                    </a:solidFill>
+                  </a:tcPr>
+                </a:tc>
+              </a:tr>
+              <a:tr h="475488">
+                <a:tc>
+                  <a:txBody>
+                    <a:bodyPr/>
+                    <a:lstStyle/>
+                    <a:p>
+                      <a:pPr algn="ctr"/>
+                      <a:r>
+                        <a:rPr sz="1150" b="1" i="0">
+                          <a:solidFill>
+                            <a:srgbClr val="1C2833"/>
+                          </a:solidFill>
+                          <a:latin typeface="Malgun Gothic"/>
+                        </a:rPr>
+                        <a:t>5</a:t>
+                      </a:r>
+                    </a:p>
+                  </a:txBody>
+                  <a:tcPr marL="73152" marR="73152" marT="18288" marB="18288" anchor="ctr">
+                    <a:lnB w="9525" cap="flat" cmpd="sng" algn="ctr">
+                      <a:solidFill>
+                        <a:srgbClr val="D5DBDB"/>
+                      </a:solidFill>
+                    </a:lnB>
+                    <a:lnT w="9525" cap="flat" cmpd="sng" algn="ctr">
+                      <a:solidFill>
+                        <a:srgbClr val="FFFFFF"/>
+                      </a:solidFill>
+                    </a:lnT>
+                    <a:lnR w="9525" cap="flat" cmpd="sng" algn="ctr">
+                      <a:solidFill>
+                        <a:srgbClr val="FFFFFF"/>
+                      </a:solidFill>
+                    </a:lnR>
+                    <a:lnL w="9525" cap="flat" cmpd="sng" algn="ctr">
+                      <a:solidFill>
+                        <a:srgbClr val="FFFFFF"/>
+                      </a:solidFill>
+                    </a:lnL>
+                    <a:solidFill>
+                      <a:srgbClr val="FFFFFF"/>
+                    </a:solidFill>
+                  </a:tcPr>
+                </a:tc>
+                <a:tc>
+                  <a:txBody>
+                    <a:bodyPr/>
+                    <a:lstStyle/>
+                    <a:p>
+                      <a:pPr algn="l"/>
+                      <a:r>
+                        <a:rPr sz="1150" b="0" i="0">
+                          <a:solidFill>
+                            <a:srgbClr val="1C2833"/>
+                          </a:solidFill>
+                          <a:latin typeface="Malgun Gothic"/>
+                        </a:rPr>
+                        <a:t>판정 워커 분리</a:t>
+                      </a:r>
+                    </a:p>
+                  </a:txBody>
+                  <a:tcPr marL="73152" marR="73152" marT="18288" marB="18288" anchor="ctr">
+                    <a:lnB w="9525" cap="flat" cmpd="sng" algn="ctr">
+                      <a:solidFill>
+                        <a:srgbClr val="D5DBDB"/>
+                      </a:solidFill>
+                    </a:lnB>
+                    <a:lnT w="9525" cap="flat" cmpd="sng" algn="ctr">
+                      <a:solidFill>
+                        <a:srgbClr val="FFFFFF"/>
+                      </a:solidFill>
+                    </a:lnT>
+                    <a:lnR w="9525" cap="flat" cmpd="sng" algn="ctr">
+                      <a:solidFill>
+                        <a:srgbClr val="FFFFFF"/>
+                      </a:solidFill>
+                    </a:lnR>
+                    <a:lnL w="9525" cap="flat" cmpd="sng" algn="ctr">
+                      <a:solidFill>
+                        <a:srgbClr val="FFFFFF"/>
+                      </a:solidFill>
+                    </a:lnL>
+                    <a:solidFill>
+                      <a:srgbClr val="FFFFFF"/>
+                    </a:solidFill>
+                  </a:tcPr>
+                </a:tc>
+                <a:tc>
+                  <a:txBody>
+                    <a:bodyPr/>
+                    <a:lstStyle/>
+                    <a:p>
+                      <a:pPr algn="l"/>
+                      <a:r>
+                        <a:rPr sz="1150" b="0" i="0">
+                          <a:solidFill>
+                            <a:srgbClr val="1C2833"/>
+                          </a:solidFill>
+                          <a:latin typeface="Malgun Gothic"/>
+                        </a:rPr>
+                        <a:t>20대 이상에서 화면이 끊기지 않는가</a:t>
+                      </a:r>
+                    </a:p>
+                  </a:txBody>
+                  <a:tcPr marL="73152" marR="73152" marT="18288" marB="18288" anchor="ctr">
+                    <a:lnB w="9525" cap="flat" cmpd="sng" algn="ctr">
+                      <a:solidFill>
+                        <a:srgbClr val="D5DBDB"/>
+                      </a:solidFill>
+                    </a:lnB>
+                    <a:lnT w="9525" cap="flat" cmpd="sng" algn="ctr">
+                      <a:solidFill>
+                        <a:srgbClr val="FFFFFF"/>
+                      </a:solidFill>
+                    </a:lnT>
+                    <a:lnR w="9525" cap="flat" cmpd="sng" algn="ctr">
+                      <a:solidFill>
+                        <a:srgbClr val="FFFFFF"/>
+                      </a:solidFill>
+                    </a:lnR>
+                    <a:lnL w="9525" cap="flat" cmpd="sng" algn="ctr">
+                      <a:solidFill>
+                        <a:srgbClr val="FFFFFF"/>
+                      </a:solidFill>
+                    </a:lnL>
+                    <a:solidFill>
+                      <a:srgbClr val="FFFFFF"/>
+                    </a:solidFill>
+                  </a:tcPr>
+                </a:tc>
+                <a:tc>
+                  <a:txBody>
+                    <a:bodyPr/>
+                    <a:lstStyle/>
+                    <a:p>
+                      <a:pPr algn="ctr"/>
+                      <a:r>
+                        <a:rPr sz="1150" b="0" i="0">
+                          <a:solidFill>
+                            <a:srgbClr val="1C2833"/>
+                          </a:solidFill>
+                          <a:latin typeface="Malgun Gothic"/>
+                        </a:rPr>
+                        <a:t>예정</a:t>
+                      </a:r>
+                    </a:p>
+                  </a:txBody>
+                  <a:tcPr marL="73152" marR="73152" marT="18288" marB="18288" anchor="ctr">
+                    <a:lnB w="9525" cap="flat" cmpd="sng" algn="ctr">
+                      <a:solidFill>
+                        <a:srgbClr val="D5DBDB"/>
+                      </a:solidFill>
+                    </a:lnB>
+                    <a:lnT w="9525" cap="flat" cmpd="sng" algn="ctr">
+                      <a:solidFill>
+                        <a:srgbClr val="FFFFFF"/>
+                      </a:solidFill>
+                    </a:lnT>
+                    <a:lnR w="9525" cap="flat" cmpd="sng" algn="ctr">
+                      <a:solidFill>
+                        <a:srgbClr val="FFFFFF"/>
+                      </a:solidFill>
+                    </a:lnR>
+                    <a:lnL w="9525" cap="flat" cmpd="sng" algn="ctr">
+                      <a:solidFill>
+                        <a:srgbClr val="FFFFFF"/>
+                      </a:solidFill>
+                    </a:lnL>
+                    <a:solidFill>
+                      <a:srgbClr val="FFFFFF"/>
+                    </a:solidFill>
+                  </a:tcPr>
+                </a:tc>
+              </a:tr>
+            </a:tbl>
+          </a:graphicData>
+        </a:graphic>
+      </p:graphicFrame>
+      <p:sp>
+        <p:nvSpPr>
+          <p:cNvPr id="16" name="Rectangle 15"/>
+          <p:cNvSpPr/>
+          <p:nvPr/>
+        </p:nvSpPr>
+        <p:spPr>
+          <a:xfrm>
+            <a:off x="640080" y="4315968"/>
+            <a:ext cx="1463040" cy="301752"/>
+          </a:xfrm>
+          <a:prstGeom prst="rect">
+            <a:avLst/>
+          </a:prstGeom>
+          <a:solidFill>
+            <a:srgbClr val="8C8C8C"/>
+          </a:solidFill>
+          <a:ln>
+            <a:noFill/>
+          </a:ln>
+          <a:effectLst/>
+        </p:spPr>
+        <p:style>
+          <a:lnRef idx="1">
+            <a:schemeClr val="accent1"/>
+          </a:lnRef>
+          <a:fillRef idx="3">
+            <a:schemeClr val="accent1"/>
+          </a:fillRef>
+          <a:effectRef idx="2">
+            <a:schemeClr val="accent1"/>
+          </a:effectRef>
+          <a:fontRef idx="minor">
+            <a:schemeClr val="lt1"/>
+          </a:fontRef>
+        </p:style>
+        <p:txBody>
+          <a:bodyPr rtlCol="0" anchor="ctr" wrap="square" lIns="36576" rIns="36576" tIns="0" bIns="0"/>
+          <a:lstStyle/>
+          <a:p>
+            <a:pPr algn="ctr"/>
+            <a:r>
+              <a:rPr sz="1100" b="1" i="0">
+                <a:solidFill>
+                  <a:srgbClr val="FFFFFF"/>
+                </a:solidFill>
+                <a:latin typeface="Malgun Gothic"/>
+              </a:rPr>
+              <a:t>이 순서인 이유</a:t>
+            </a:r>
+          </a:p>
+        </p:txBody>
+      </p:sp>
+      <p:sp>
+        <p:nvSpPr>
+          <p:cNvPr id="17" name="TextBox 16"/>
+          <p:cNvSpPr txBox="1"/>
+          <p:nvPr/>
+        </p:nvSpPr>
+        <p:spPr>
+          <a:xfrm>
+            <a:off x="868680" y="4773168"/>
+            <a:ext cx="10881360" cy="365760"/>
+          </a:xfrm>
+          <a:prstGeom prst="rect">
+            <a:avLst/>
+          </a:prstGeom>
+          <a:noFill/>
+        </p:spPr>
+        <p:txBody>
+          <a:bodyPr wrap="square" lIns="36576" rIns="36576" tIns="0" bIns="0">
+            <a:spAutoFit/>
+          </a:bodyPr>
+          <a:lstStyle/>
+          <a:p>
+            <a:pPr algn="l">
+              <a:spcAft>
+                <a:spcPts val="400"/>
+              </a:spcAft>
+            </a:pPr>
+            <a:r>
+              <a:rPr sz="1150" b="0" i="0">
+                <a:solidFill>
+                  <a:srgbClr val="1C2833"/>
+                </a:solidFill>
+                <a:latin typeface="Malgun Gothic"/>
+              </a:rPr>
+              <a:t>①  측정 수단이 먼저다 — 테스트 0건 상태에서 안전 로직을 분해하면, 회귀를 현장에서 발견하는 방식이 그대로 남는다</a:t>
+            </a:r>
+          </a:p>
+        </p:txBody>
+      </p:sp>
+      <p:sp>
+        <p:nvSpPr>
+          <p:cNvPr id="18" name="TextBox 17"/>
+          <p:cNvSpPr txBox="1"/>
+          <p:nvPr/>
+        </p:nvSpPr>
+        <p:spPr>
+          <a:xfrm>
+            <a:off x="868680" y="5157216"/>
+            <a:ext cx="10881360" cy="365760"/>
+          </a:xfrm>
+          <a:prstGeom prst="rect">
+            <a:avLst/>
+          </a:prstGeom>
+          <a:noFill/>
+        </p:spPr>
+        <p:txBody>
+          <a:bodyPr wrap="square" lIns="36576" rIns="36576" tIns="0" bIns="0">
+            <a:spAutoFit/>
+          </a:bodyPr>
+          <a:lstStyle/>
+          <a:p>
+            <a:pPr algn="l">
+              <a:spcAft>
+                <a:spcPts val="400"/>
+              </a:spcAft>
+            </a:pPr>
+            <a:r>
+              <a:rPr sz="1150" b="0" i="0">
+                <a:solidFill>
+                  <a:srgbClr val="1C2833"/>
+                </a:solidFill>
+                <a:latin typeface="Malgun Gothic"/>
+              </a:rPr>
+              <a:t>②  단계마다 단독 배포한다 — 변경을 섞어 내보내면 현장에서 회귀가 나도 어느 변경 탓인지 특정할 수 없다</a:t>
+            </a:r>
+          </a:p>
+        </p:txBody>
+      </p:sp>
+      <p:sp>
+        <p:nvSpPr>
+          <p:cNvPr id="19" name="TextBox 18"/>
+          <p:cNvSpPr txBox="1"/>
+          <p:nvPr/>
+        </p:nvSpPr>
+        <p:spPr>
+          <a:xfrm>
+            <a:off x="640080" y="5687568"/>
+            <a:ext cx="10908792" cy="384048"/>
+          </a:xfrm>
+          <a:prstGeom prst="rect">
+            <a:avLst/>
+          </a:prstGeom>
+          <a:noFill/>
+        </p:spPr>
+        <p:txBody>
+          <a:bodyPr wrap="square" lIns="36576" rIns="36576" tIns="0" bIns="0">
+            <a:spAutoFit/>
+          </a:bodyPr>
+          <a:lstStyle/>
+          <a:p>
+            <a:pPr algn="ctr"/>
+            <a:r>
+              <a:rPr sz="1500" b="1" i="0">
+                <a:solidFill>
+                  <a:srgbClr val="C0392B"/>
+                </a:solidFill>
+                <a:latin typeface="Malgun Gothic"/>
+              </a:rPr>
+              <a:t>1. </a:t>
+            </a:r>
+            <a:r>
+              <a:rPr sz="1500" b="1" i="0">
+                <a:solidFill>
+                  <a:srgbClr val="1C2833"/>
+                </a:solidFill>
+                <a:latin typeface="Malgun Gothic"/>
+              </a:rPr>
+              <a:t>완료 1 / 5      </a:t>
+            </a:r>
+            <a:r>
+              <a:rPr sz="1500" b="1" i="0">
+                <a:solidFill>
+                  <a:srgbClr val="C0392B"/>
+                </a:solidFill>
+                <a:latin typeface="Malgun Gothic"/>
+              </a:rPr>
+              <a:t>2. </a:t>
+            </a:r>
+            <a:r>
+              <a:rPr sz="1500" b="1" i="0">
+                <a:solidFill>
+                  <a:srgbClr val="1C2833"/>
+                </a:solidFill>
+                <a:latin typeface="Malgun Gothic"/>
+              </a:rPr>
+              <a:t>전 단계 출하 가능      </a:t>
+            </a:r>
+            <a:r>
+              <a:rPr sz="1500" b="1" i="0">
+                <a:solidFill>
+                  <a:srgbClr val="C0392B"/>
+                </a:solidFill>
+                <a:latin typeface="Malgun Gothic"/>
+              </a:rPr>
+              <a:t>3. </a:t>
+            </a:r>
+            <a:r>
+              <a:rPr sz="1500" b="1" i="0">
+                <a:solidFill>
+                  <a:srgbClr val="1C2833"/>
+                </a:solidFill>
+                <a:latin typeface="Malgun Gothic"/>
+              </a:rPr>
+              <a:t>현장 확인은 단계당 1건</a:t>
+            </a:r>
+          </a:p>
+        </p:txBody>
+      </p:sp>
+    </p:spTree>
+    <p:extLst>
+      <p:ext uri="{BB962C8B-B14F-4D97-AF65-F5344CB8AC3E}">
+        <p14:creationId xmlns:p14="http://schemas.microsoft.com/office/powerpoint/2010/main" val="3987384774"/>
+      </p:ext>
+    </p:extLst>
+  </p:cSld>
+  <p:clrMapOvr>
+    <a:masterClrMapping/>
+  </p:clrMapOvr>
+</p:sld>
+</file>
+
+<file path=ppt/slides/slide9.xml><?xml version="1.0" encoding="utf-8"?>
+<p:sld xmlns:a="http://schemas.openxmlformats.org/drawingml/2006/main" xmlns:r="http://schemas.openxmlformats.org/officeDocument/2006/relationships" xmlns:p="http://schemas.openxmlformats.org/presentationml/2006/main">
+  <p:cSld>
+    <p:spTree>
+      <p:nvGrpSpPr>
+        <p:cNvPr id="1" name="">
+          <a:extLst>
+            <a:ext uri="{FF2B5EF4-FFF2-40B4-BE49-F238E27FC236}">
+              <a16:creationId xmlns:a16="http://schemas.microsoft.com/office/drawing/2014/main" id="{E4EFD6F4-EBDD-9AC2-DC28-2DDF0C04A565}"/>
+            </a:ext>
+          </a:extLst>
+        </p:cNvPr>
+        <p:cNvGrpSpPr/>
+        <p:nvPr/>
+      </p:nvGrpSpPr>
+      <p:grpSpPr>
+        <a:xfrm>
+          <a:off x="0" y="0"/>
+          <a:ext cx="0" cy="0"/>
+          <a:chOff x="0" y="0"/>
+          <a:chExt cx="0" cy="0"/>
+        </a:xfrm>
+      </p:grpSpPr>
+      <p:sp>
+        <p:nvSpPr>
+          <p:cNvPr id="5" name="제목 1">
+            <a:extLst>
+              <a:ext uri="{FF2B5EF4-FFF2-40B4-BE49-F238E27FC236}">
+                <a16:creationId xmlns:a16="http://schemas.microsoft.com/office/drawing/2014/main" id="{3462F1EA-748D-175E-1C14-5E9984552716}"/>
+              </a:ext>
+            </a:extLst>
+          </p:cNvPr>
+          <p:cNvSpPr txBox="1">
+            <a:spLocks/>
+          </p:cNvSpPr>
+          <p:nvPr/>
+        </p:nvSpPr>
+        <p:spPr>
+          <a:xfrm>
+            <a:off x="636390" y="928122"/>
+            <a:ext cx="11342595" cy="3980770"/>
+          </a:xfrm>
+          <a:prstGeom prst="rect">
+            <a:avLst/>
+          </a:prstGeom>
+          <a:noFill/>
+        </p:spPr>
+        <p:txBody>
+          <a:bodyPr vert="horz" wrap="square" lIns="91440" tIns="45720" rIns="91440" bIns="45720" rtlCol="0" anchor="t">
+            <a:spAutoFit/>
+          </a:bodyPr>
+          <a:lstStyle>
+            <a:lvl1pPr marL="0" indent="0" algn="l" defTabSz="914400" rtl="0" eaLnBrk="1" latinLnBrk="1" hangingPunct="1">
+              <a:lnSpc>
+                <a:spcPct val="100000"/>
+              </a:lnSpc>
+              <a:spcBef>
+                <a:spcPct val="0"/>
+              </a:spcBef>
+              <a:buNone/>
+              <a:defRPr lang="en-US" sz="1600" b="1" kern="1200" dirty="0">
+                <a:solidFill>
+                  <a:srgbClr val="560000"/>
+                </a:solidFill>
+                <a:latin typeface="+mj-ea"/>
+                <a:ea typeface="+mj-ea"/>
+                <a:cs typeface="+mn-cs"/>
+              </a:defRPr>
+            </a:lvl1pPr>
+          </a:lstStyle>
+          <a:p>
+            <a:pPr>
+              <a:lnSpc>
+                <a:spcPct val="150000"/>
+              </a:lnSpc>
+            </a:pPr>
+            <a:endParaRPr lang="en-US" altLang="ko-KR" sz="1400" dirty="0">
+              <a:solidFill>
+                <a:schemeClr val="tx1"/>
+              </a:solidFill>
+              <a:latin typeface="+mn-ea"/>
+              <a:ea typeface="+mn-ea"/>
+            </a:endParaRPr>
+          </a:p>
+        </p:txBody>
+      </p:sp>
+      <p:sp>
+        <p:nvSpPr>
+          <p:cNvPr id="2" name="제목 1">
+            <a:extLst>
+              <a:ext uri="{FF2B5EF4-FFF2-40B4-BE49-F238E27FC236}">
+                <a16:creationId xmlns:a16="http://schemas.microsoft.com/office/drawing/2014/main" id="{54B5B938-7AFE-1302-EB19-024D633AA023}"/>
+              </a:ext>
+            </a:extLst>
+          </p:cNvPr>
+          <p:cNvSpPr>
+            <a:spLocks noGrp="1"/>
+          </p:cNvSpPr>
+          <p:nvPr>
+            <p:ph type="title"/>
+          </p:nvPr>
+        </p:nvSpPr>
+        <p:spPr>
+          <a:xfrm>
+            <a:off x="636391" y="595686"/>
+            <a:ext cx="11293263" cy="338554"/>
+          </a:xfrm>
+        </p:spPr>
+        <p:txBody>
+          <a:bodyPr/>
+          <a:lstStyle/>
+          <a:p>
+            <a:r>
+              <a:rPr lang="en-US" altLang="ko-KR" dirty="0">
+                <a:latin typeface="맑은 고딕" panose="020B0503020000020004" pitchFamily="50" charset="-127"/>
+                <a:ea typeface="맑은 고딕" panose="020B0503020000020004" pitchFamily="50" charset="-127"/>
+              </a:rPr>
+              <a:t>7. Andon — 중단 · 롤백 기준</a:t>
+            </a:r>
+            <a:endParaRPr lang="ko-KR" altLang="en-US" dirty="0"/>
+          </a:p>
+        </p:txBody>
+      </p:sp>
+      <p:sp>
+        <p:nvSpPr>
+          <p:cNvPr id="12" name="슬라이드 번호 개체 틀 11">
+            <a:extLst>
+              <a:ext uri="{FF2B5EF4-FFF2-40B4-BE49-F238E27FC236}">
+                <a16:creationId xmlns:a16="http://schemas.microsoft.com/office/drawing/2014/main" id="{B7184ABC-D9FC-E120-072A-5615A9569176}"/>
+              </a:ext>
+            </a:extLst>
+          </p:cNvPr>
+          <p:cNvSpPr>
+            <a:spLocks noGrp="1"/>
+          </p:cNvSpPr>
+          <p:nvPr>
+            <p:ph type="sldNum" sz="quarter" idx="12"/>
+          </p:nvPr>
+        </p:nvSpPr>
+        <p:spPr/>
+        <p:txBody>
+          <a:bodyPr/>
+          <a:lstStyle/>
+          <a:p>
+            <a:fld id="{A2CF8A37-2FCE-495B-9275-FE23C56C2D36}" type="slidenum">
+              <a:rPr lang="ko-KR" altLang="en-US" smtClean="0"/>
+              <a:pPr/>
+              <a:t>4</a:t>
+            </a:fld>
+            <a:endParaRPr lang="ko-KR" altLang="en-US" dirty="0"/>
+          </a:p>
+        </p:txBody>
+      </p:sp>
+      <p:sp>
+        <p:nvSpPr>
+          <p:cNvPr id="13" name="Rectangle 12"/>
+          <p:cNvSpPr/>
+          <p:nvPr/>
+        </p:nvSpPr>
+        <p:spPr>
+          <a:xfrm>
+            <a:off x="640080" y="1024128"/>
+            <a:ext cx="1371600" cy="301752"/>
+          </a:xfrm>
+          <a:prstGeom prst="rect">
+            <a:avLst/>
+          </a:prstGeom>
+          <a:solidFill>
+            <a:srgbClr val="8C8C8C"/>
+          </a:solidFill>
+          <a:ln>
+            <a:noFill/>
+          </a:ln>
+          <a:effectLst/>
+        </p:spPr>
+        <p:style>
+          <a:lnRef idx="1">
+            <a:schemeClr val="accent1"/>
+          </a:lnRef>
+          <a:fillRef idx="3">
+            <a:schemeClr val="accent1"/>
+          </a:fillRef>
+          <a:effectRef idx="2">
+            <a:schemeClr val="accent1"/>
+          </a:effectRef>
+          <a:fontRef idx="minor">
+            <a:schemeClr val="lt1"/>
+          </a:fontRef>
+        </p:style>
+        <p:txBody>
+          <a:bodyPr rtlCol="0" anchor="ctr" wrap="square" lIns="36576" rIns="36576" tIns="0" bIns="0"/>
+          <a:lstStyle/>
+          <a:p>
+            <a:pPr algn="ctr"/>
+            <a:r>
+              <a:rPr sz="1100" b="1" i="0">
+                <a:solidFill>
+                  <a:srgbClr val="FFFFFF"/>
+                </a:solidFill>
+                <a:latin typeface="Malgun Gothic"/>
+              </a:rPr>
+              <a:t>Andon 기준</a:t>
+            </a:r>
+          </a:p>
+        </p:txBody>
+      </p:sp>
+      <p:sp>
+        <p:nvSpPr>
+          <p:cNvPr id="14" name="Rectangle 13"/>
+          <p:cNvSpPr/>
+          <p:nvPr/>
+        </p:nvSpPr>
+        <p:spPr>
+          <a:xfrm>
+            <a:off x="6355080" y="1024128"/>
+            <a:ext cx="1371600" cy="301752"/>
+          </a:xfrm>
+          <a:prstGeom prst="rect">
+            <a:avLst/>
+          </a:prstGeom>
+          <a:solidFill>
+            <a:srgbClr val="8C8C8C"/>
+          </a:solidFill>
+          <a:ln>
+            <a:noFill/>
+          </a:ln>
+          <a:effectLst/>
+        </p:spPr>
+        <p:style>
+          <a:lnRef idx="1">
+            <a:schemeClr val="accent1"/>
+          </a:lnRef>
+          <a:fillRef idx="3">
+            <a:schemeClr val="accent1"/>
+          </a:fillRef>
+          <a:effectRef idx="2">
+            <a:schemeClr val="accent1"/>
+          </a:effectRef>
+          <a:fontRef idx="minor">
+            <a:schemeClr val="lt1"/>
+          </a:fontRef>
+        </p:style>
+        <p:txBody>
+          <a:bodyPr rtlCol="0" anchor="ctr" wrap="square" lIns="36576" rIns="36576" tIns="0" bIns="0"/>
+          <a:lstStyle/>
+          <a:p>
+            <a:pPr algn="ctr"/>
+            <a:r>
+              <a:rPr sz="1100" b="1" i="0">
+                <a:solidFill>
+                  <a:srgbClr val="FFFFFF"/>
+                </a:solidFill>
+                <a:latin typeface="Malgun Gothic"/>
+              </a:rPr>
+              <a:t>조치 방법</a:t>
+            </a:r>
+          </a:p>
+        </p:txBody>
+      </p:sp>
+      <p:sp>
+        <p:nvSpPr>
+          <p:cNvPr id="15" name="TextBox 14"/>
+          <p:cNvSpPr txBox="1"/>
+          <p:nvPr/>
+        </p:nvSpPr>
+        <p:spPr>
+          <a:xfrm>
+            <a:off x="822960" y="1517904"/>
+            <a:ext cx="5120640" cy="1005840"/>
+          </a:xfrm>
+          <a:prstGeom prst="rect">
+            <a:avLst/>
+          </a:prstGeom>
+          <a:noFill/>
+        </p:spPr>
+        <p:txBody>
+          <a:bodyPr wrap="square" lIns="36576" rIns="36576" tIns="0" bIns="0">
+            <a:spAutoFit/>
+          </a:bodyPr>
+          <a:lstStyle/>
+          <a:p>
+            <a:pPr algn="l">
+              <a:spcAft>
+                <a:spcPts val="300"/>
+              </a:spcAft>
+            </a:pPr>
+            <a:r>
+              <a:rPr sz="1300" b="1" i="0">
+                <a:solidFill>
+                  <a:srgbClr val="C0392B"/>
+                </a:solidFill>
+                <a:latin typeface="Malgun Gothic"/>
+              </a:rPr>
+              <a:t>동작 보존 실패</a:t>
+            </a:r>
+          </a:p>
+          <a:p>
+            <a:pPr algn="l">
+              <a:spcAft>
+                <a:spcPts val="300"/>
+              </a:spcAft>
+            </a:pPr>
+            <a:r>
+              <a:rPr sz="1150" b="0" i="0">
+                <a:solidFill>
+                  <a:srgbClr val="5D6D7E"/>
+                </a:solidFill>
+                <a:latin typeface="Malgun Gothic"/>
+              </a:rPr>
+              <a:t>분해 전후로 골든 테스트 기대값이 한 건이라도 바뀌면
+그 단계는 통과가 아니다 (Phase 3 수용 게이트)</a:t>
+            </a:r>
+          </a:p>
+        </p:txBody>
+      </p:sp>
+      <p:sp>
+        <p:nvSpPr>
+          <p:cNvPr id="16" name="TextBox 15"/>
+          <p:cNvSpPr txBox="1"/>
+          <p:nvPr/>
+        </p:nvSpPr>
+        <p:spPr>
+          <a:xfrm>
+            <a:off x="6537960" y="1517904"/>
+            <a:ext cx="5120640" cy="1005840"/>
+          </a:xfrm>
+          <a:prstGeom prst="rect">
+            <a:avLst/>
+          </a:prstGeom>
+          <a:noFill/>
+        </p:spPr>
+        <p:txBody>
+          <a:bodyPr wrap="square" lIns="36576" rIns="36576" tIns="0" bIns="0">
+            <a:spAutoFit/>
+          </a:bodyPr>
+          <a:lstStyle/>
+          <a:p>
+            <a:pPr algn="l">
+              <a:spcAft>
+                <a:spcPts val="300"/>
+              </a:spcAft>
+            </a:pPr>
+            <a:r>
+              <a:rPr sz="1300" b="1" i="0">
+                <a:solidFill>
+                  <a:srgbClr val="1C2833"/>
+                </a:solidFill>
+                <a:latin typeface="Malgun Gothic"/>
+              </a:rPr>
+              <a:t>즉시 롤백</a:t>
+            </a:r>
+          </a:p>
+          <a:p>
+            <a:pPr algn="l">
+              <a:spcAft>
+                <a:spcPts val="300"/>
+              </a:spcAft>
+            </a:pPr>
+            <a:r>
+              <a:rPr sz="1150" b="0" i="0">
+                <a:solidFill>
+                  <a:srgbClr val="5D6D7E"/>
+                </a:solidFill>
+                <a:latin typeface="Malgun Gothic"/>
+              </a:rPr>
+              <a:t>직전 태그 APK 로 되돌린다. 자동 업데이트 경로가 있어
+현장 재설치 없이 배포된다</a:t>
+            </a:r>
+          </a:p>
+        </p:txBody>
+      </p:sp>
+      <p:sp>
+        <p:nvSpPr>
+          <p:cNvPr id="17" name="TextBox 16"/>
+          <p:cNvSpPr txBox="1"/>
+          <p:nvPr/>
+        </p:nvSpPr>
+        <p:spPr>
+          <a:xfrm>
+            <a:off x="822960" y="2651760"/>
+            <a:ext cx="5120640" cy="1005840"/>
+          </a:xfrm>
+          <a:prstGeom prst="rect">
+            <a:avLst/>
+          </a:prstGeom>
+          <a:noFill/>
+        </p:spPr>
+        <p:txBody>
+          <a:bodyPr wrap="square" lIns="36576" rIns="36576" tIns="0" bIns="0">
+            <a:spAutoFit/>
+          </a:bodyPr>
+          <a:lstStyle/>
+          <a:p>
+            <a:pPr algn="l">
+              <a:spcAft>
+                <a:spcPts val="300"/>
+              </a:spcAft>
+            </a:pPr>
+            <a:r>
+              <a:rPr sz="1300" b="1" i="0">
+                <a:solidFill>
+                  <a:srgbClr val="C0392B"/>
+                </a:solidFill>
+                <a:latin typeface="Malgun Gothic"/>
+              </a:rPr>
+              <a:t>현장 회귀 재발</a:t>
+            </a:r>
+          </a:p>
+          <a:p>
+            <a:pPr algn="l">
+              <a:spcAft>
+                <a:spcPts val="300"/>
+              </a:spcAft>
+            </a:pPr>
+            <a:r>
+              <a:rPr sz="1150" b="0" i="0">
+                <a:solidFill>
+                  <a:srgbClr val="5D6D7E"/>
+                </a:solidFill>
+                <a:latin typeface="Malgun Gothic"/>
+              </a:rPr>
+              <a:t>이전에 고친 증상(미발령 · 상시 경보 · 사이렌 반복)이
+다시 관측되면 그 단계를 중단한다</a:t>
+            </a:r>
+          </a:p>
+        </p:txBody>
+      </p:sp>
+      <p:sp>
+        <p:nvSpPr>
+          <p:cNvPr id="18" name="TextBox 17"/>
+          <p:cNvSpPr txBox="1"/>
+          <p:nvPr/>
+        </p:nvSpPr>
+        <p:spPr>
+          <a:xfrm>
+            <a:off x="6537960" y="2651760"/>
+            <a:ext cx="5120640" cy="1005840"/>
+          </a:xfrm>
+          <a:prstGeom prst="rect">
+            <a:avLst/>
+          </a:prstGeom>
+          <a:noFill/>
+        </p:spPr>
+        <p:txBody>
+          <a:bodyPr wrap="square" lIns="36576" rIns="36576" tIns="0" bIns="0">
+            <a:spAutoFit/>
+          </a:bodyPr>
+          <a:lstStyle/>
+          <a:p>
+            <a:pPr algn="l">
+              <a:spcAft>
+                <a:spcPts val="300"/>
+              </a:spcAft>
+            </a:pPr>
+            <a:r>
+              <a:rPr sz="1300" b="1" i="0">
+                <a:solidFill>
+                  <a:srgbClr val="1C2833"/>
+                </a:solidFill>
+                <a:latin typeface="Malgun Gothic"/>
+              </a:rPr>
+              <a:t>원인 귀속</a:t>
+            </a:r>
+          </a:p>
+          <a:p>
+            <a:pPr algn="l">
+              <a:spcAft>
+                <a:spcPts val="300"/>
+              </a:spcAft>
+            </a:pPr>
+            <a:r>
+              <a:rPr sz="1150" b="0" i="0">
+                <a:solidFill>
+                  <a:srgbClr val="5D6D7E"/>
+                </a:solidFill>
+                <a:latin typeface="Malgun Gothic"/>
+              </a:rPr>
+              <a:t>단계를 단독 배포하기 때문에 회귀가 나면 어느 변경
+탓인지 특정된다</a:t>
+            </a:r>
+          </a:p>
+        </p:txBody>
+      </p:sp>
+      <p:sp>
+        <p:nvSpPr>
+          <p:cNvPr id="19" name="TextBox 18"/>
+          <p:cNvSpPr txBox="1"/>
+          <p:nvPr/>
+        </p:nvSpPr>
+        <p:spPr>
+          <a:xfrm>
+            <a:off x="822960" y="3785615"/>
+            <a:ext cx="5120640" cy="1005840"/>
+          </a:xfrm>
+          <a:prstGeom prst="rect">
+            <a:avLst/>
+          </a:prstGeom>
+          <a:noFill/>
+        </p:spPr>
+        <p:txBody>
+          <a:bodyPr wrap="square" lIns="36576" rIns="36576" tIns="0" bIns="0">
+            <a:spAutoFit/>
+          </a:bodyPr>
+          <a:lstStyle/>
+          <a:p>
+            <a:pPr algn="l">
+              <a:spcAft>
+                <a:spcPts val="300"/>
+              </a:spcAft>
+            </a:pPr>
+            <a:r>
+              <a:rPr sz="1300" b="1" i="0">
+                <a:solidFill>
+                  <a:srgbClr val="C0392B"/>
+                </a:solidFill>
+                <a:latin typeface="Malgun Gothic"/>
+              </a:rPr>
+              <a:t>CI 게이트 적색</a:t>
+            </a:r>
+          </a:p>
+          <a:p>
+            <a:pPr algn="l">
+              <a:spcAft>
+                <a:spcPts val="300"/>
+              </a:spcAft>
+            </a:pPr>
+            <a:r>
+              <a:rPr sz="1150" b="0" i="0">
+                <a:solidFill>
+                  <a:srgbClr val="5D6D7E"/>
+                </a:solidFill>
+                <a:latin typeface="Malgun Gothic"/>
+              </a:rPr>
+              <a:t>골든 테스트가 실패하면 APK 릴리스가 자동 차단된다
+— 이미 동작 중인 장치다</a:t>
+            </a:r>
+          </a:p>
+        </p:txBody>
+      </p:sp>
+      <p:sp>
+        <p:nvSpPr>
+          <p:cNvPr id="20" name="TextBox 19"/>
+          <p:cNvSpPr txBox="1"/>
+          <p:nvPr/>
+        </p:nvSpPr>
+        <p:spPr>
+          <a:xfrm>
+            <a:off x="6537960" y="3785615"/>
+            <a:ext cx="5120640" cy="1005840"/>
+          </a:xfrm>
+          <a:prstGeom prst="rect">
+            <a:avLst/>
+          </a:prstGeom>
+          <a:noFill/>
+        </p:spPr>
+        <p:txBody>
+          <a:bodyPr wrap="square" lIns="36576" rIns="36576" tIns="0" bIns="0">
+            <a:spAutoFit/>
+          </a:bodyPr>
+          <a:lstStyle/>
+          <a:p>
+            <a:pPr algn="l">
+              <a:spcAft>
+                <a:spcPts val="300"/>
+              </a:spcAft>
+            </a:pPr>
+            <a:r>
+              <a:rPr sz="1300" b="1" i="0">
+                <a:solidFill>
+                  <a:srgbClr val="1C2833"/>
+                </a:solidFill>
+                <a:latin typeface="Malgun Gothic"/>
+              </a:rPr>
+              <a:t>재개 조건</a:t>
+            </a:r>
+          </a:p>
+          <a:p>
+            <a:pPr algn="l">
+              <a:spcAft>
+                <a:spcPts val="300"/>
+              </a:spcAft>
+            </a:pPr>
+            <a:r>
+              <a:rPr sz="1150" b="0" i="0">
+                <a:solidFill>
+                  <a:srgbClr val="5D6D7E"/>
+                </a:solidFill>
+                <a:latin typeface="Malgun Gothic"/>
+              </a:rPr>
+              <a:t>실패한 상황을 테스트로 고정한 뒤에만 다음 단계로
+넘어간다 — 같은 증상이 두 번 돌아오지 않게</a:t>
+            </a:r>
+          </a:p>
+        </p:txBody>
+      </p:sp>
+      <p:sp>
+        <p:nvSpPr>
+          <p:cNvPr id="21" name="TextBox 20"/>
+          <p:cNvSpPr txBox="1"/>
+          <p:nvPr/>
+        </p:nvSpPr>
+        <p:spPr>
+          <a:xfrm>
+            <a:off x="822960" y="4919472"/>
+            <a:ext cx="5120640" cy="1005840"/>
+          </a:xfrm>
+          <a:prstGeom prst="rect">
+            <a:avLst/>
+          </a:prstGeom>
+          <a:noFill/>
+        </p:spPr>
+        <p:txBody>
+          <a:bodyPr wrap="square" lIns="36576" rIns="36576" tIns="0" bIns="0">
+            <a:spAutoFit/>
+          </a:bodyPr>
+          <a:lstStyle/>
+          <a:p>
+            <a:pPr algn="l">
+              <a:spcAft>
+                <a:spcPts val="300"/>
+              </a:spcAft>
+            </a:pPr>
+            <a:r>
+              <a:rPr sz="1300" b="1" i="0">
+                <a:solidFill>
+                  <a:srgbClr val="C0392B"/>
+                </a:solidFill>
+                <a:latin typeface="Malgun Gothic"/>
+              </a:rPr>
+              <a:t>UWB 의존 파손</a:t>
+            </a:r>
+          </a:p>
+          <a:p>
+            <a:pPr algn="l">
+              <a:spcAft>
+                <a:spcPts val="300"/>
+              </a:spcAft>
+            </a:pPr>
+            <a:r>
+              <a:rPr sz="1150" b="0" i="0">
+                <a:solidFill>
+                  <a:srgbClr val="5D6D7E"/>
+                </a:solidFill>
+                <a:latin typeface="Malgun Gothic"/>
+              </a:rPr>
+              <a:t>프리릴리스 UWB API 의 파괴 변경으로 경로가 깨지면
+UWB 를 끄고 BLE 단독으로 내린다</a:t>
+            </a:r>
+          </a:p>
+        </p:txBody>
+      </p:sp>
+      <p:sp>
+        <p:nvSpPr>
+          <p:cNvPr id="22" name="TextBox 21"/>
+          <p:cNvSpPr txBox="1"/>
+          <p:nvPr/>
+        </p:nvSpPr>
+        <p:spPr>
+          <a:xfrm>
+            <a:off x="6537960" y="4919472"/>
+            <a:ext cx="5120640" cy="1005840"/>
+          </a:xfrm>
+          <a:prstGeom prst="rect">
+            <a:avLst/>
+          </a:prstGeom>
+          <a:noFill/>
+        </p:spPr>
+        <p:txBody>
+          <a:bodyPr wrap="square" lIns="36576" rIns="36576" tIns="0" bIns="0">
+            <a:spAutoFit/>
+          </a:bodyPr>
+          <a:lstStyle/>
+          <a:p>
+            <a:pPr algn="l">
+              <a:spcAft>
+                <a:spcPts val="300"/>
+              </a:spcAft>
+            </a:pPr>
+            <a:r>
+              <a:rPr sz="1300" b="1" i="0">
+                <a:solidFill>
+                  <a:srgbClr val="1C2833"/>
+                </a:solidFill>
+                <a:latin typeface="Malgun Gothic"/>
+              </a:rPr>
+              <a:t>현장 부담</a:t>
+            </a:r>
+          </a:p>
+          <a:p>
+            <a:pPr algn="l">
+              <a:spcAft>
+                <a:spcPts val="300"/>
+              </a:spcAft>
+            </a:pPr>
+            <a:r>
+              <a:rPr sz="1150" b="0" i="0">
+                <a:solidFill>
+                  <a:srgbClr val="5D6D7E"/>
+                </a:solidFill>
+                <a:latin typeface="Malgun Gothic"/>
+              </a:rPr>
+              <a:t>확인 항목은 단계당 1건으로 제한한다. 검증 사이클이
+현장 가용 시간에 묶여 있다</a:t>
+            </a:r>
+          </a:p>
+        </p:txBody>
+      </p:sp>
+      <p:sp>
+        <p:nvSpPr>
+          <p:cNvPr id="23" name="TextBox 22"/>
+          <p:cNvSpPr txBox="1"/>
+          <p:nvPr/>
+        </p:nvSpPr>
+        <p:spPr>
+          <a:xfrm>
+            <a:off x="640080" y="6053328"/>
+            <a:ext cx="7680960" cy="365760"/>
+          </a:xfrm>
+          <a:prstGeom prst="rect">
+            <a:avLst/>
+          </a:prstGeom>
+          <a:noFill/>
+        </p:spPr>
+        <p:txBody>
+          <a:bodyPr wrap="square" lIns="36576" rIns="36576" tIns="0" bIns="0">
+            <a:spAutoFit/>
+          </a:bodyPr>
+          <a:lstStyle/>
+          <a:p>
+            <a:pPr algn="ctr"/>
+            <a:r>
+              <a:rPr sz="1150" b="0" i="1">
+                <a:solidFill>
+                  <a:srgbClr val="5D6D7E"/>
+                </a:solidFill>
+                <a:latin typeface="Malgun Gothic"/>
+              </a:rPr>
+              <a:t>“멈출 기준을 먼저 정해 두는 것이, 멈추지 않고 밀어붙이는 것보다 빠릅니다.”</a:t>
+            </a:r>
+          </a:p>
+        </p:txBody>
+      </p:sp>
+    </p:spTree>
+    <p:extLst>
+      <p:ext uri="{BB962C8B-B14F-4D97-AF65-F5344CB8AC3E}">
+        <p14:creationId xmlns:p14="http://schemas.microsoft.com/office/powerpoint/2010/main" val="3987384774"/>
+      </p:ext>
+    </p:extLst>
+  </p:cSld>
+  <p:clrMapOvr>
+    <a:masterClrMapping/>
+  </p:clrMapOvr>
 </p:sld>
 </file>
 

</xml_diff>